<commit_message>
Refresh the presentation with the final measured results
Both slide decks still showed 228 / 2 / 67 from before the vision pass. They now
carry 261 / 2 / 43 across 306 checks, with the per-type breakdown to match, and
say plainly that the deterministic path alone scores 230 / 2 / 72 so the two
configurations are not confused with each other.

Co-Authored-By: Claude Opus 5 <noreply@anthropic.com>
Claude-Session: https://claude.ai/code/session_01KDihiRTYzTrgWmqHF4z1nu
</commit_message>
<xml_diff>
--- a/docs/solution_presentation.pptx
+++ b/docs/solution_presentation.pptx
@@ -4923,7 +4923,7 @@
                 <a:ea typeface="Calibri" pitchFamily="34" charset="-122"/>
                 <a:cs typeface="Calibri" pitchFamily="34" charset="-120"/>
               </a:rPr>
-              <a:t>All 50 documents in the provided dataset, 297 financial checks</a:t>
+              <a:t>All 50 documents, 306 financial checks, with the Gemini vision pass</a:t>
             </a:r>
             <a:endParaRPr lang="en-US" sz="1500" dirty="0"/>
           </a:p>
@@ -5009,7 +5009,7 @@
                 <a:ea typeface="Cambria" pitchFamily="34" charset="-122"/>
                 <a:cs typeface="Cambria" pitchFamily="34" charset="-120"/>
               </a:rPr>
-              <a:t>228</a:t>
+              <a:t>261</a:t>
             </a:r>
             <a:endParaRPr lang="en-US" sz="4000" dirty="0"/>
           </a:p>
@@ -5227,7 +5227,7 @@
                 <a:ea typeface="Cambria" pitchFamily="34" charset="-122"/>
                 <a:cs typeface="Cambria" pitchFamily="34" charset="-120"/>
               </a:rPr>
-              <a:t>67</a:t>
+              <a:t>43</a:t>
             </a:r>
             <a:endParaRPr lang="en-US" sz="4000" dirty="0"/>
           </a:p>
@@ -5308,7 +5308,7 @@
                 <a:ea typeface="Calibri" pitchFamily="34" charset="-122"/>
                 <a:cs typeface="Calibri" pitchFamily="34" charset="-120"/>
               </a:rPr>
-              <a:t>Every statement check reconciles. The two failures were read back against the source images and are real: a receipt whose items total $3,480 against a printed $5,257, and one whose change is RM 2.00 short. Not-applicable results concentrate in the 2020–2022 scans, where OCR cannot recover row labels.</a:t>
+              <a:t>Every statement check that can be evaluated now passes. The two failures were read back against the source images and are real: a receipt whose items total $3,480 against a printed $5,257, and one whose change is RM 2.00 short. Deterministic OCR alone scores 230/2/72; the vision pass recovers the rest.</a:t>
             </a:r>
             <a:endParaRPr lang="en-US" sz="1050" dirty="0"/>
           </a:p>

</xml_diff>